<commit_message>
Update presentation deck with logos on all slides
Agent-Logs-Url: https://github.com/khairullah770/skilled-laborer-updated/sessions/4210efda-6087-4979-b2a8-b8e33109536d

Co-authored-by: khairullah770 <115985051+khairullah770@users.noreply.github.com>
</commit_message>
<xml_diff>
--- a/Skilled_Labor_App_Presentation.pptx
+++ b/Skilled_Labor_App_Presentation.pptx
@@ -3366,6 +3366,54 @@
           </a:p>
         </p:txBody>
       </p:sp>
+      <p:pic>
+        <p:nvPicPr>
+          <p:cNvPr id="9" name="Picture 8" descr="logo2.png"/>
+          <p:cNvPicPr>
+            <a:picLocks noChangeAspect="1"/>
+          </p:cNvPicPr>
+          <p:nvPr/>
+        </p:nvPicPr>
+        <p:blipFill>
+          <a:blip r:embed="rId2"/>
+          <a:stretch>
+            <a:fillRect/>
+          </a:stretch>
+        </p:blipFill>
+        <p:spPr>
+          <a:xfrm>
+            <a:off x="164592" y="91440"/>
+            <a:ext cx="640080" cy="327894"/>
+          </a:xfrm>
+          <a:prstGeom prst="rect">
+            <a:avLst/>
+          </a:prstGeom>
+        </p:spPr>
+      </p:pic>
+      <p:pic>
+        <p:nvPicPr>
+          <p:cNvPr id="10" name="Picture 9" descr="logo.png"/>
+          <p:cNvPicPr>
+            <a:picLocks noChangeAspect="1"/>
+          </p:cNvPicPr>
+          <p:nvPr/>
+        </p:nvPicPr>
+        <p:blipFill>
+          <a:blip r:embed="rId3"/>
+          <a:stretch>
+            <a:fillRect/>
+          </a:stretch>
+        </p:blipFill>
+        <p:spPr>
+          <a:xfrm>
+            <a:off x="11457432" y="91440"/>
+            <a:ext cx="566928" cy="566928"/>
+          </a:xfrm>
+          <a:prstGeom prst="rect">
+            <a:avLst/>
+          </a:prstGeom>
+        </p:spPr>
+      </p:pic>
     </p:spTree>
   </p:cSld>
   <p:clrMapOvr>
@@ -4662,6 +4710,54 @@
           </a:p>
         </p:txBody>
       </p:sp>
+      <p:pic>
+        <p:nvPicPr>
+          <p:cNvPr id="26" name="Picture 25" descr="logo2.png"/>
+          <p:cNvPicPr>
+            <a:picLocks noChangeAspect="1"/>
+          </p:cNvPicPr>
+          <p:nvPr/>
+        </p:nvPicPr>
+        <p:blipFill>
+          <a:blip r:embed="rId2"/>
+          <a:stretch>
+            <a:fillRect/>
+          </a:stretch>
+        </p:blipFill>
+        <p:spPr>
+          <a:xfrm>
+            <a:off x="164592" y="91440"/>
+            <a:ext cx="640080" cy="327894"/>
+          </a:xfrm>
+          <a:prstGeom prst="rect">
+            <a:avLst/>
+          </a:prstGeom>
+        </p:spPr>
+      </p:pic>
+      <p:pic>
+        <p:nvPicPr>
+          <p:cNvPr id="27" name="Picture 26" descr="logo.png"/>
+          <p:cNvPicPr>
+            <a:picLocks noChangeAspect="1"/>
+          </p:cNvPicPr>
+          <p:nvPr/>
+        </p:nvPicPr>
+        <p:blipFill>
+          <a:blip r:embed="rId3"/>
+          <a:stretch>
+            <a:fillRect/>
+          </a:stretch>
+        </p:blipFill>
+        <p:spPr>
+          <a:xfrm>
+            <a:off x="11457432" y="91440"/>
+            <a:ext cx="566928" cy="566928"/>
+          </a:xfrm>
+          <a:prstGeom prst="rect">
+            <a:avLst/>
+          </a:prstGeom>
+        </p:spPr>
+      </p:pic>
     </p:spTree>
   </p:cSld>
   <p:clrMapOvr>
@@ -6017,6 +6113,54 @@
           </a:p>
         </p:txBody>
       </p:sp>
+      <p:pic>
+        <p:nvPicPr>
+          <p:cNvPr id="34" name="Picture 33" descr="logo2.png"/>
+          <p:cNvPicPr>
+            <a:picLocks noChangeAspect="1"/>
+          </p:cNvPicPr>
+          <p:nvPr/>
+        </p:nvPicPr>
+        <p:blipFill>
+          <a:blip r:embed="rId2"/>
+          <a:stretch>
+            <a:fillRect/>
+          </a:stretch>
+        </p:blipFill>
+        <p:spPr>
+          <a:xfrm>
+            <a:off x="164592" y="91440"/>
+            <a:ext cx="640080" cy="327894"/>
+          </a:xfrm>
+          <a:prstGeom prst="rect">
+            <a:avLst/>
+          </a:prstGeom>
+        </p:spPr>
+      </p:pic>
+      <p:pic>
+        <p:nvPicPr>
+          <p:cNvPr id="35" name="Picture 34" descr="logo.png"/>
+          <p:cNvPicPr>
+            <a:picLocks noChangeAspect="1"/>
+          </p:cNvPicPr>
+          <p:nvPr/>
+        </p:nvPicPr>
+        <p:blipFill>
+          <a:blip r:embed="rId3"/>
+          <a:stretch>
+            <a:fillRect/>
+          </a:stretch>
+        </p:blipFill>
+        <p:spPr>
+          <a:xfrm>
+            <a:off x="11457432" y="91440"/>
+            <a:ext cx="566928" cy="566928"/>
+          </a:xfrm>
+          <a:prstGeom prst="rect">
+            <a:avLst/>
+          </a:prstGeom>
+        </p:spPr>
+      </p:pic>
     </p:spTree>
   </p:cSld>
   <p:clrMapOvr>
@@ -7615,6 +7759,54 @@
           </a:p>
         </p:txBody>
       </p:sp>
+      <p:pic>
+        <p:nvPicPr>
+          <p:cNvPr id="40" name="Picture 39" descr="logo2.png"/>
+          <p:cNvPicPr>
+            <a:picLocks noChangeAspect="1"/>
+          </p:cNvPicPr>
+          <p:nvPr/>
+        </p:nvPicPr>
+        <p:blipFill>
+          <a:blip r:embed="rId2"/>
+          <a:stretch>
+            <a:fillRect/>
+          </a:stretch>
+        </p:blipFill>
+        <p:spPr>
+          <a:xfrm>
+            <a:off x="164592" y="91440"/>
+            <a:ext cx="640080" cy="327894"/>
+          </a:xfrm>
+          <a:prstGeom prst="rect">
+            <a:avLst/>
+          </a:prstGeom>
+        </p:spPr>
+      </p:pic>
+      <p:pic>
+        <p:nvPicPr>
+          <p:cNvPr id="41" name="Picture 40" descr="logo.png"/>
+          <p:cNvPicPr>
+            <a:picLocks noChangeAspect="1"/>
+          </p:cNvPicPr>
+          <p:nvPr/>
+        </p:nvPicPr>
+        <p:blipFill>
+          <a:blip r:embed="rId3"/>
+          <a:stretch>
+            <a:fillRect/>
+          </a:stretch>
+        </p:blipFill>
+        <p:spPr>
+          <a:xfrm>
+            <a:off x="11457432" y="91440"/>
+            <a:ext cx="566928" cy="566928"/>
+          </a:xfrm>
+          <a:prstGeom prst="rect">
+            <a:avLst/>
+          </a:prstGeom>
+        </p:spPr>
+      </p:pic>
     </p:spTree>
   </p:cSld>
   <p:clrMapOvr>
@@ -8481,6 +8673,54 @@
           </a:p>
         </p:txBody>
       </p:sp>
+      <p:pic>
+        <p:nvPicPr>
+          <p:cNvPr id="17" name="Picture 16" descr="logo2.png"/>
+          <p:cNvPicPr>
+            <a:picLocks noChangeAspect="1"/>
+          </p:cNvPicPr>
+          <p:nvPr/>
+        </p:nvPicPr>
+        <p:blipFill>
+          <a:blip r:embed="rId2"/>
+          <a:stretch>
+            <a:fillRect/>
+          </a:stretch>
+        </p:blipFill>
+        <p:spPr>
+          <a:xfrm>
+            <a:off x="164592" y="91440"/>
+            <a:ext cx="640080" cy="327894"/>
+          </a:xfrm>
+          <a:prstGeom prst="rect">
+            <a:avLst/>
+          </a:prstGeom>
+        </p:spPr>
+      </p:pic>
+      <p:pic>
+        <p:nvPicPr>
+          <p:cNvPr id="18" name="Picture 17" descr="logo.png"/>
+          <p:cNvPicPr>
+            <a:picLocks noChangeAspect="1"/>
+          </p:cNvPicPr>
+          <p:nvPr/>
+        </p:nvPicPr>
+        <p:blipFill>
+          <a:blip r:embed="rId3"/>
+          <a:stretch>
+            <a:fillRect/>
+          </a:stretch>
+        </p:blipFill>
+        <p:spPr>
+          <a:xfrm>
+            <a:off x="11457432" y="91440"/>
+            <a:ext cx="566928" cy="566928"/>
+          </a:xfrm>
+          <a:prstGeom prst="rect">
+            <a:avLst/>
+          </a:prstGeom>
+        </p:spPr>
+      </p:pic>
     </p:spTree>
   </p:cSld>
   <p:clrMapOvr>
@@ -9781,6 +10021,54 @@
           </a:p>
         </p:txBody>
       </p:sp>
+      <p:pic>
+        <p:nvPicPr>
+          <p:cNvPr id="32" name="Picture 31" descr="logo2.png"/>
+          <p:cNvPicPr>
+            <a:picLocks noChangeAspect="1"/>
+          </p:cNvPicPr>
+          <p:nvPr/>
+        </p:nvPicPr>
+        <p:blipFill>
+          <a:blip r:embed="rId2"/>
+          <a:stretch>
+            <a:fillRect/>
+          </a:stretch>
+        </p:blipFill>
+        <p:spPr>
+          <a:xfrm>
+            <a:off x="164592" y="91440"/>
+            <a:ext cx="640080" cy="327894"/>
+          </a:xfrm>
+          <a:prstGeom prst="rect">
+            <a:avLst/>
+          </a:prstGeom>
+        </p:spPr>
+      </p:pic>
+      <p:pic>
+        <p:nvPicPr>
+          <p:cNvPr id="33" name="Picture 32" descr="logo.png"/>
+          <p:cNvPicPr>
+            <a:picLocks noChangeAspect="1"/>
+          </p:cNvPicPr>
+          <p:nvPr/>
+        </p:nvPicPr>
+        <p:blipFill>
+          <a:blip r:embed="rId3"/>
+          <a:stretch>
+            <a:fillRect/>
+          </a:stretch>
+        </p:blipFill>
+        <p:spPr>
+          <a:xfrm>
+            <a:off x="11457432" y="91440"/>
+            <a:ext cx="566928" cy="566928"/>
+          </a:xfrm>
+          <a:prstGeom prst="rect">
+            <a:avLst/>
+          </a:prstGeom>
+        </p:spPr>
+      </p:pic>
     </p:spTree>
   </p:cSld>
   <p:clrMapOvr>
@@ -11693,6 +11981,54 @@
           </a:p>
         </p:txBody>
       </p:sp>
+      <p:pic>
+        <p:nvPicPr>
+          <p:cNvPr id="47" name="Picture 46" descr="logo2.png"/>
+          <p:cNvPicPr>
+            <a:picLocks noChangeAspect="1"/>
+          </p:cNvPicPr>
+          <p:nvPr/>
+        </p:nvPicPr>
+        <p:blipFill>
+          <a:blip r:embed="rId2"/>
+          <a:stretch>
+            <a:fillRect/>
+          </a:stretch>
+        </p:blipFill>
+        <p:spPr>
+          <a:xfrm>
+            <a:off x="164592" y="91440"/>
+            <a:ext cx="640080" cy="327894"/>
+          </a:xfrm>
+          <a:prstGeom prst="rect">
+            <a:avLst/>
+          </a:prstGeom>
+        </p:spPr>
+      </p:pic>
+      <p:pic>
+        <p:nvPicPr>
+          <p:cNvPr id="48" name="Picture 47" descr="logo.png"/>
+          <p:cNvPicPr>
+            <a:picLocks noChangeAspect="1"/>
+          </p:cNvPicPr>
+          <p:nvPr/>
+        </p:nvPicPr>
+        <p:blipFill>
+          <a:blip r:embed="rId3"/>
+          <a:stretch>
+            <a:fillRect/>
+          </a:stretch>
+        </p:blipFill>
+        <p:spPr>
+          <a:xfrm>
+            <a:off x="11457432" y="91440"/>
+            <a:ext cx="566928" cy="566928"/>
+          </a:xfrm>
+          <a:prstGeom prst="rect">
+            <a:avLst/>
+          </a:prstGeom>
+        </p:spPr>
+      </p:pic>
     </p:spTree>
   </p:cSld>
   <p:clrMapOvr>
@@ -13366,6 +13702,54 @@
           </a:p>
         </p:txBody>
       </p:sp>
+      <p:pic>
+        <p:nvPicPr>
+          <p:cNvPr id="43" name="Picture 42" descr="logo2.png"/>
+          <p:cNvPicPr>
+            <a:picLocks noChangeAspect="1"/>
+          </p:cNvPicPr>
+          <p:nvPr/>
+        </p:nvPicPr>
+        <p:blipFill>
+          <a:blip r:embed="rId2"/>
+          <a:stretch>
+            <a:fillRect/>
+          </a:stretch>
+        </p:blipFill>
+        <p:spPr>
+          <a:xfrm>
+            <a:off x="164592" y="91440"/>
+            <a:ext cx="640080" cy="327894"/>
+          </a:xfrm>
+          <a:prstGeom prst="rect">
+            <a:avLst/>
+          </a:prstGeom>
+        </p:spPr>
+      </p:pic>
+      <p:pic>
+        <p:nvPicPr>
+          <p:cNvPr id="44" name="Picture 43" descr="logo.png"/>
+          <p:cNvPicPr>
+            <a:picLocks noChangeAspect="1"/>
+          </p:cNvPicPr>
+          <p:nvPr/>
+        </p:nvPicPr>
+        <p:blipFill>
+          <a:blip r:embed="rId3"/>
+          <a:stretch>
+            <a:fillRect/>
+          </a:stretch>
+        </p:blipFill>
+        <p:spPr>
+          <a:xfrm>
+            <a:off x="11457432" y="91440"/>
+            <a:ext cx="566928" cy="566928"/>
+          </a:xfrm>
+          <a:prstGeom prst="rect">
+            <a:avLst/>
+          </a:prstGeom>
+        </p:spPr>
+      </p:pic>
     </p:spTree>
   </p:cSld>
   <p:clrMapOvr>
@@ -14947,6 +15331,54 @@
           </a:p>
         </p:txBody>
       </p:sp>
+      <p:pic>
+        <p:nvPicPr>
+          <p:cNvPr id="44" name="Picture 43" descr="logo2.png"/>
+          <p:cNvPicPr>
+            <a:picLocks noChangeAspect="1"/>
+          </p:cNvPicPr>
+          <p:nvPr/>
+        </p:nvPicPr>
+        <p:blipFill>
+          <a:blip r:embed="rId2"/>
+          <a:stretch>
+            <a:fillRect/>
+          </a:stretch>
+        </p:blipFill>
+        <p:spPr>
+          <a:xfrm>
+            <a:off x="164592" y="91440"/>
+            <a:ext cx="640080" cy="327894"/>
+          </a:xfrm>
+          <a:prstGeom prst="rect">
+            <a:avLst/>
+          </a:prstGeom>
+        </p:spPr>
+      </p:pic>
+      <p:pic>
+        <p:nvPicPr>
+          <p:cNvPr id="45" name="Picture 44" descr="logo.png"/>
+          <p:cNvPicPr>
+            <a:picLocks noChangeAspect="1"/>
+          </p:cNvPicPr>
+          <p:nvPr/>
+        </p:nvPicPr>
+        <p:blipFill>
+          <a:blip r:embed="rId3"/>
+          <a:stretch>
+            <a:fillRect/>
+          </a:stretch>
+        </p:blipFill>
+        <p:spPr>
+          <a:xfrm>
+            <a:off x="11457432" y="91440"/>
+            <a:ext cx="566928" cy="566928"/>
+          </a:xfrm>
+          <a:prstGeom prst="rect">
+            <a:avLst/>
+          </a:prstGeom>
+        </p:spPr>
+      </p:pic>
     </p:spTree>
   </p:cSld>
   <p:clrMapOvr>
@@ -16386,6 +16818,54 @@
           </a:p>
         </p:txBody>
       </p:sp>
+      <p:pic>
+        <p:nvPicPr>
+          <p:cNvPr id="28" name="Picture 27" descr="logo2.png"/>
+          <p:cNvPicPr>
+            <a:picLocks noChangeAspect="1"/>
+          </p:cNvPicPr>
+          <p:nvPr/>
+        </p:nvPicPr>
+        <p:blipFill>
+          <a:blip r:embed="rId2"/>
+          <a:stretch>
+            <a:fillRect/>
+          </a:stretch>
+        </p:blipFill>
+        <p:spPr>
+          <a:xfrm>
+            <a:off x="164592" y="91440"/>
+            <a:ext cx="640080" cy="327894"/>
+          </a:xfrm>
+          <a:prstGeom prst="rect">
+            <a:avLst/>
+          </a:prstGeom>
+        </p:spPr>
+      </p:pic>
+      <p:pic>
+        <p:nvPicPr>
+          <p:cNvPr id="29" name="Picture 28" descr="logo.png"/>
+          <p:cNvPicPr>
+            <a:picLocks noChangeAspect="1"/>
+          </p:cNvPicPr>
+          <p:nvPr/>
+        </p:nvPicPr>
+        <p:blipFill>
+          <a:blip r:embed="rId3"/>
+          <a:stretch>
+            <a:fillRect/>
+          </a:stretch>
+        </p:blipFill>
+        <p:spPr>
+          <a:xfrm>
+            <a:off x="11457432" y="91440"/>
+            <a:ext cx="566928" cy="566928"/>
+          </a:xfrm>
+          <a:prstGeom prst="rect">
+            <a:avLst/>
+          </a:prstGeom>
+        </p:spPr>
+      </p:pic>
     </p:spTree>
   </p:cSld>
   <p:clrMapOvr>
@@ -19013,6 +19493,54 @@
           </a:p>
         </p:txBody>
       </p:sp>
+      <p:pic>
+        <p:nvPicPr>
+          <p:cNvPr id="72" name="Picture 71" descr="logo2.png"/>
+          <p:cNvPicPr>
+            <a:picLocks noChangeAspect="1"/>
+          </p:cNvPicPr>
+          <p:nvPr/>
+        </p:nvPicPr>
+        <p:blipFill>
+          <a:blip r:embed="rId2"/>
+          <a:stretch>
+            <a:fillRect/>
+          </a:stretch>
+        </p:blipFill>
+        <p:spPr>
+          <a:xfrm>
+            <a:off x="164592" y="91440"/>
+            <a:ext cx="640080" cy="327894"/>
+          </a:xfrm>
+          <a:prstGeom prst="rect">
+            <a:avLst/>
+          </a:prstGeom>
+        </p:spPr>
+      </p:pic>
+      <p:pic>
+        <p:nvPicPr>
+          <p:cNvPr id="73" name="Picture 72" descr="logo.png"/>
+          <p:cNvPicPr>
+            <a:picLocks noChangeAspect="1"/>
+          </p:cNvPicPr>
+          <p:nvPr/>
+        </p:nvPicPr>
+        <p:blipFill>
+          <a:blip r:embed="rId3"/>
+          <a:stretch>
+            <a:fillRect/>
+          </a:stretch>
+        </p:blipFill>
+        <p:spPr>
+          <a:xfrm>
+            <a:off x="11457432" y="91440"/>
+            <a:ext cx="566928" cy="566928"/>
+          </a:xfrm>
+          <a:prstGeom prst="rect">
+            <a:avLst/>
+          </a:prstGeom>
+        </p:spPr>
+      </p:pic>
     </p:spTree>
   </p:cSld>
   <p:clrMapOvr>
@@ -21482,6 +22010,54 @@
           </a:p>
         </p:txBody>
       </p:sp>
+      <p:pic>
+        <p:nvPicPr>
+          <p:cNvPr id="68" name="Picture 67" descr="logo2.png"/>
+          <p:cNvPicPr>
+            <a:picLocks noChangeAspect="1"/>
+          </p:cNvPicPr>
+          <p:nvPr/>
+        </p:nvPicPr>
+        <p:blipFill>
+          <a:blip r:embed="rId2"/>
+          <a:stretch>
+            <a:fillRect/>
+          </a:stretch>
+        </p:blipFill>
+        <p:spPr>
+          <a:xfrm>
+            <a:off x="164592" y="91440"/>
+            <a:ext cx="640080" cy="327894"/>
+          </a:xfrm>
+          <a:prstGeom prst="rect">
+            <a:avLst/>
+          </a:prstGeom>
+        </p:spPr>
+      </p:pic>
+      <p:pic>
+        <p:nvPicPr>
+          <p:cNvPr id="69" name="Picture 68" descr="logo.png"/>
+          <p:cNvPicPr>
+            <a:picLocks noChangeAspect="1"/>
+          </p:cNvPicPr>
+          <p:nvPr/>
+        </p:nvPicPr>
+        <p:blipFill>
+          <a:blip r:embed="rId3"/>
+          <a:stretch>
+            <a:fillRect/>
+          </a:stretch>
+        </p:blipFill>
+        <p:spPr>
+          <a:xfrm>
+            <a:off x="11457432" y="91440"/>
+            <a:ext cx="566928" cy="566928"/>
+          </a:xfrm>
+          <a:prstGeom prst="rect">
+            <a:avLst/>
+          </a:prstGeom>
+        </p:spPr>
+      </p:pic>
     </p:spTree>
   </p:cSld>
   <p:clrMapOvr>
@@ -22826,6 +23402,54 @@
           </a:p>
         </p:txBody>
       </p:sp>
+      <p:pic>
+        <p:nvPicPr>
+          <p:cNvPr id="26" name="Picture 25" descr="logo2.png"/>
+          <p:cNvPicPr>
+            <a:picLocks noChangeAspect="1"/>
+          </p:cNvPicPr>
+          <p:nvPr/>
+        </p:nvPicPr>
+        <p:blipFill>
+          <a:blip r:embed="rId2"/>
+          <a:stretch>
+            <a:fillRect/>
+          </a:stretch>
+        </p:blipFill>
+        <p:spPr>
+          <a:xfrm>
+            <a:off x="164592" y="91440"/>
+            <a:ext cx="640080" cy="327894"/>
+          </a:xfrm>
+          <a:prstGeom prst="rect">
+            <a:avLst/>
+          </a:prstGeom>
+        </p:spPr>
+      </p:pic>
+      <p:pic>
+        <p:nvPicPr>
+          <p:cNvPr id="27" name="Picture 26" descr="logo.png"/>
+          <p:cNvPicPr>
+            <a:picLocks noChangeAspect="1"/>
+          </p:cNvPicPr>
+          <p:nvPr/>
+        </p:nvPicPr>
+        <p:blipFill>
+          <a:blip r:embed="rId3"/>
+          <a:stretch>
+            <a:fillRect/>
+          </a:stretch>
+        </p:blipFill>
+        <p:spPr>
+          <a:xfrm>
+            <a:off x="11457432" y="91440"/>
+            <a:ext cx="566928" cy="566928"/>
+          </a:xfrm>
+          <a:prstGeom prst="rect">
+            <a:avLst/>
+          </a:prstGeom>
+        </p:spPr>
+      </p:pic>
     </p:spTree>
   </p:cSld>
   <p:clrMapOvr>
@@ -24431,6 +25055,54 @@
           </a:p>
         </p:txBody>
       </p:sp>
+      <p:pic>
+        <p:nvPicPr>
+          <p:cNvPr id="44" name="Picture 43" descr="logo2.png"/>
+          <p:cNvPicPr>
+            <a:picLocks noChangeAspect="1"/>
+          </p:cNvPicPr>
+          <p:nvPr/>
+        </p:nvPicPr>
+        <p:blipFill>
+          <a:blip r:embed="rId2"/>
+          <a:stretch>
+            <a:fillRect/>
+          </a:stretch>
+        </p:blipFill>
+        <p:spPr>
+          <a:xfrm>
+            <a:off x="164592" y="91440"/>
+            <a:ext cx="640080" cy="327894"/>
+          </a:xfrm>
+          <a:prstGeom prst="rect">
+            <a:avLst/>
+          </a:prstGeom>
+        </p:spPr>
+      </p:pic>
+      <p:pic>
+        <p:nvPicPr>
+          <p:cNvPr id="45" name="Picture 44" descr="logo.png"/>
+          <p:cNvPicPr>
+            <a:picLocks noChangeAspect="1"/>
+          </p:cNvPicPr>
+          <p:nvPr/>
+        </p:nvPicPr>
+        <p:blipFill>
+          <a:blip r:embed="rId3"/>
+          <a:stretch>
+            <a:fillRect/>
+          </a:stretch>
+        </p:blipFill>
+        <p:spPr>
+          <a:xfrm>
+            <a:off x="11457432" y="91440"/>
+            <a:ext cx="566928" cy="566928"/>
+          </a:xfrm>
+          <a:prstGeom prst="rect">
+            <a:avLst/>
+          </a:prstGeom>
+        </p:spPr>
+      </p:pic>
     </p:spTree>
   </p:cSld>
   <p:clrMapOvr>
@@ -25576,6 +26248,54 @@
           </a:p>
         </p:txBody>
       </p:sp>
+      <p:pic>
+        <p:nvPicPr>
+          <p:cNvPr id="32" name="Picture 31" descr="logo2.png"/>
+          <p:cNvPicPr>
+            <a:picLocks noChangeAspect="1"/>
+          </p:cNvPicPr>
+          <p:nvPr/>
+        </p:nvPicPr>
+        <p:blipFill>
+          <a:blip r:embed="rId2"/>
+          <a:stretch>
+            <a:fillRect/>
+          </a:stretch>
+        </p:blipFill>
+        <p:spPr>
+          <a:xfrm>
+            <a:off x="164592" y="91440"/>
+            <a:ext cx="640080" cy="327894"/>
+          </a:xfrm>
+          <a:prstGeom prst="rect">
+            <a:avLst/>
+          </a:prstGeom>
+        </p:spPr>
+      </p:pic>
+      <p:pic>
+        <p:nvPicPr>
+          <p:cNvPr id="33" name="Picture 32" descr="logo.png"/>
+          <p:cNvPicPr>
+            <a:picLocks noChangeAspect="1"/>
+          </p:cNvPicPr>
+          <p:nvPr/>
+        </p:nvPicPr>
+        <p:blipFill>
+          <a:blip r:embed="rId3"/>
+          <a:stretch>
+            <a:fillRect/>
+          </a:stretch>
+        </p:blipFill>
+        <p:spPr>
+          <a:xfrm>
+            <a:off x="11457432" y="91440"/>
+            <a:ext cx="566928" cy="566928"/>
+          </a:xfrm>
+          <a:prstGeom prst="rect">
+            <a:avLst/>
+          </a:prstGeom>
+        </p:spPr>
+      </p:pic>
     </p:spTree>
   </p:cSld>
   <p:clrMapOvr>
@@ -26097,6 +26817,54 @@
           </a:p>
         </p:txBody>
       </p:sp>
+      <p:pic>
+        <p:nvPicPr>
+          <p:cNvPr id="16" name="Picture 15" descr="logo2.png"/>
+          <p:cNvPicPr>
+            <a:picLocks noChangeAspect="1"/>
+          </p:cNvPicPr>
+          <p:nvPr/>
+        </p:nvPicPr>
+        <p:blipFill>
+          <a:blip r:embed="rId2"/>
+          <a:stretch>
+            <a:fillRect/>
+          </a:stretch>
+        </p:blipFill>
+        <p:spPr>
+          <a:xfrm>
+            <a:off x="164592" y="91440"/>
+            <a:ext cx="640080" cy="327894"/>
+          </a:xfrm>
+          <a:prstGeom prst="rect">
+            <a:avLst/>
+          </a:prstGeom>
+        </p:spPr>
+      </p:pic>
+      <p:pic>
+        <p:nvPicPr>
+          <p:cNvPr id="17" name="Picture 16" descr="logo.png"/>
+          <p:cNvPicPr>
+            <a:picLocks noChangeAspect="1"/>
+          </p:cNvPicPr>
+          <p:nvPr/>
+        </p:nvPicPr>
+        <p:blipFill>
+          <a:blip r:embed="rId3"/>
+          <a:stretch>
+            <a:fillRect/>
+          </a:stretch>
+        </p:blipFill>
+        <p:spPr>
+          <a:xfrm>
+            <a:off x="11457432" y="91440"/>
+            <a:ext cx="566928" cy="566928"/>
+          </a:xfrm>
+          <a:prstGeom prst="rect">
+            <a:avLst/>
+          </a:prstGeom>
+        </p:spPr>
+      </p:pic>
     </p:spTree>
   </p:cSld>
   <p:clrMapOvr>
@@ -26739,6 +27507,54 @@
           </a:p>
         </p:txBody>
       </p:sp>
+      <p:pic>
+        <p:nvPicPr>
+          <p:cNvPr id="13" name="Picture 12" descr="logo2.png"/>
+          <p:cNvPicPr>
+            <a:picLocks noChangeAspect="1"/>
+          </p:cNvPicPr>
+          <p:nvPr/>
+        </p:nvPicPr>
+        <p:blipFill>
+          <a:blip r:embed="rId2"/>
+          <a:stretch>
+            <a:fillRect/>
+          </a:stretch>
+        </p:blipFill>
+        <p:spPr>
+          <a:xfrm>
+            <a:off x="164592" y="91440"/>
+            <a:ext cx="640080" cy="327894"/>
+          </a:xfrm>
+          <a:prstGeom prst="rect">
+            <a:avLst/>
+          </a:prstGeom>
+        </p:spPr>
+      </p:pic>
+      <p:pic>
+        <p:nvPicPr>
+          <p:cNvPr id="14" name="Picture 13" descr="logo.png"/>
+          <p:cNvPicPr>
+            <a:picLocks noChangeAspect="1"/>
+          </p:cNvPicPr>
+          <p:nvPr/>
+        </p:nvPicPr>
+        <p:blipFill>
+          <a:blip r:embed="rId3"/>
+          <a:stretch>
+            <a:fillRect/>
+          </a:stretch>
+        </p:blipFill>
+        <p:spPr>
+          <a:xfrm>
+            <a:off x="11457432" y="91440"/>
+            <a:ext cx="566928" cy="566928"/>
+          </a:xfrm>
+          <a:prstGeom prst="rect">
+            <a:avLst/>
+          </a:prstGeom>
+        </p:spPr>
+      </p:pic>
     </p:spTree>
   </p:cSld>
   <p:clrMapOvr>
@@ -27709,6 +28525,54 @@
           </a:p>
         </p:txBody>
       </p:sp>
+      <p:pic>
+        <p:nvPicPr>
+          <p:cNvPr id="27" name="Picture 26" descr="logo2.png"/>
+          <p:cNvPicPr>
+            <a:picLocks noChangeAspect="1"/>
+          </p:cNvPicPr>
+          <p:nvPr/>
+        </p:nvPicPr>
+        <p:blipFill>
+          <a:blip r:embed="rId2"/>
+          <a:stretch>
+            <a:fillRect/>
+          </a:stretch>
+        </p:blipFill>
+        <p:spPr>
+          <a:xfrm>
+            <a:off x="164592" y="91440"/>
+            <a:ext cx="640080" cy="327894"/>
+          </a:xfrm>
+          <a:prstGeom prst="rect">
+            <a:avLst/>
+          </a:prstGeom>
+        </p:spPr>
+      </p:pic>
+      <p:pic>
+        <p:nvPicPr>
+          <p:cNvPr id="28" name="Picture 27" descr="logo.png"/>
+          <p:cNvPicPr>
+            <a:picLocks noChangeAspect="1"/>
+          </p:cNvPicPr>
+          <p:nvPr/>
+        </p:nvPicPr>
+        <p:blipFill>
+          <a:blip r:embed="rId3"/>
+          <a:stretch>
+            <a:fillRect/>
+          </a:stretch>
+        </p:blipFill>
+        <p:spPr>
+          <a:xfrm>
+            <a:off x="11457432" y="91440"/>
+            <a:ext cx="566928" cy="566928"/>
+          </a:xfrm>
+          <a:prstGeom prst="rect">
+            <a:avLst/>
+          </a:prstGeom>
+        </p:spPr>
+      </p:pic>
     </p:spTree>
   </p:cSld>
   <p:clrMapOvr>
@@ -29526,6 +30390,54 @@
           </a:p>
         </p:txBody>
       </p:sp>
+      <p:pic>
+        <p:nvPicPr>
+          <p:cNvPr id="48" name="Picture 47" descr="logo2.png"/>
+          <p:cNvPicPr>
+            <a:picLocks noChangeAspect="1"/>
+          </p:cNvPicPr>
+          <p:nvPr/>
+        </p:nvPicPr>
+        <p:blipFill>
+          <a:blip r:embed="rId2"/>
+          <a:stretch>
+            <a:fillRect/>
+          </a:stretch>
+        </p:blipFill>
+        <p:spPr>
+          <a:xfrm>
+            <a:off x="164592" y="91440"/>
+            <a:ext cx="640080" cy="327894"/>
+          </a:xfrm>
+          <a:prstGeom prst="rect">
+            <a:avLst/>
+          </a:prstGeom>
+        </p:spPr>
+      </p:pic>
+      <p:pic>
+        <p:nvPicPr>
+          <p:cNvPr id="49" name="Picture 48" descr="logo.png"/>
+          <p:cNvPicPr>
+            <a:picLocks noChangeAspect="1"/>
+          </p:cNvPicPr>
+          <p:nvPr/>
+        </p:nvPicPr>
+        <p:blipFill>
+          <a:blip r:embed="rId3"/>
+          <a:stretch>
+            <a:fillRect/>
+          </a:stretch>
+        </p:blipFill>
+        <p:spPr>
+          <a:xfrm>
+            <a:off x="11457432" y="91440"/>
+            <a:ext cx="566928" cy="566928"/>
+          </a:xfrm>
+          <a:prstGeom prst="rect">
+            <a:avLst/>
+          </a:prstGeom>
+        </p:spPr>
+      </p:pic>
     </p:spTree>
   </p:cSld>
   <p:clrMapOvr>
@@ -30565,6 +31477,54 @@
           </a:p>
         </p:txBody>
       </p:sp>
+      <p:pic>
+        <p:nvPicPr>
+          <p:cNvPr id="20" name="Picture 19" descr="logo2.png"/>
+          <p:cNvPicPr>
+            <a:picLocks noChangeAspect="1"/>
+          </p:cNvPicPr>
+          <p:nvPr/>
+        </p:nvPicPr>
+        <p:blipFill>
+          <a:blip r:embed="rId2"/>
+          <a:stretch>
+            <a:fillRect/>
+          </a:stretch>
+        </p:blipFill>
+        <p:spPr>
+          <a:xfrm>
+            <a:off x="164592" y="91440"/>
+            <a:ext cx="640080" cy="327894"/>
+          </a:xfrm>
+          <a:prstGeom prst="rect">
+            <a:avLst/>
+          </a:prstGeom>
+        </p:spPr>
+      </p:pic>
+      <p:pic>
+        <p:nvPicPr>
+          <p:cNvPr id="21" name="Picture 20" descr="logo.png"/>
+          <p:cNvPicPr>
+            <a:picLocks noChangeAspect="1"/>
+          </p:cNvPicPr>
+          <p:nvPr/>
+        </p:nvPicPr>
+        <p:blipFill>
+          <a:blip r:embed="rId3"/>
+          <a:stretch>
+            <a:fillRect/>
+          </a:stretch>
+        </p:blipFill>
+        <p:spPr>
+          <a:xfrm>
+            <a:off x="11457432" y="91440"/>
+            <a:ext cx="566928" cy="566928"/>
+          </a:xfrm>
+          <a:prstGeom prst="rect">
+            <a:avLst/>
+          </a:prstGeom>
+        </p:spPr>
+      </p:pic>
     </p:spTree>
   </p:cSld>
   <p:clrMapOvr>
@@ -32374,6 +33334,54 @@
           </a:p>
         </p:txBody>
       </p:sp>
+      <p:pic>
+        <p:nvPicPr>
+          <p:cNvPr id="48" name="Picture 47" descr="logo2.png"/>
+          <p:cNvPicPr>
+            <a:picLocks noChangeAspect="1"/>
+          </p:cNvPicPr>
+          <p:nvPr/>
+        </p:nvPicPr>
+        <p:blipFill>
+          <a:blip r:embed="rId2"/>
+          <a:stretch>
+            <a:fillRect/>
+          </a:stretch>
+        </p:blipFill>
+        <p:spPr>
+          <a:xfrm>
+            <a:off x="164592" y="91440"/>
+            <a:ext cx="640080" cy="327894"/>
+          </a:xfrm>
+          <a:prstGeom prst="rect">
+            <a:avLst/>
+          </a:prstGeom>
+        </p:spPr>
+      </p:pic>
+      <p:pic>
+        <p:nvPicPr>
+          <p:cNvPr id="49" name="Picture 48" descr="logo.png"/>
+          <p:cNvPicPr>
+            <a:picLocks noChangeAspect="1"/>
+          </p:cNvPicPr>
+          <p:nvPr/>
+        </p:nvPicPr>
+        <p:blipFill>
+          <a:blip r:embed="rId3"/>
+          <a:stretch>
+            <a:fillRect/>
+          </a:stretch>
+        </p:blipFill>
+        <p:spPr>
+          <a:xfrm>
+            <a:off x="11457432" y="91440"/>
+            <a:ext cx="566928" cy="566928"/>
+          </a:xfrm>
+          <a:prstGeom prst="rect">
+            <a:avLst/>
+          </a:prstGeom>
+        </p:spPr>
+      </p:pic>
     </p:spTree>
   </p:cSld>
   <p:clrMapOvr>
@@ -33360,6 +34368,54 @@
           </a:p>
         </p:txBody>
       </p:sp>
+      <p:pic>
+        <p:nvPicPr>
+          <p:cNvPr id="19" name="Picture 18" descr="logo2.png"/>
+          <p:cNvPicPr>
+            <a:picLocks noChangeAspect="1"/>
+          </p:cNvPicPr>
+          <p:nvPr/>
+        </p:nvPicPr>
+        <p:blipFill>
+          <a:blip r:embed="rId2"/>
+          <a:stretch>
+            <a:fillRect/>
+          </a:stretch>
+        </p:blipFill>
+        <p:spPr>
+          <a:xfrm>
+            <a:off x="164592" y="91440"/>
+            <a:ext cx="640080" cy="327894"/>
+          </a:xfrm>
+          <a:prstGeom prst="rect">
+            <a:avLst/>
+          </a:prstGeom>
+        </p:spPr>
+      </p:pic>
+      <p:pic>
+        <p:nvPicPr>
+          <p:cNvPr id="20" name="Picture 19" descr="logo.png"/>
+          <p:cNvPicPr>
+            <a:picLocks noChangeAspect="1"/>
+          </p:cNvPicPr>
+          <p:nvPr/>
+        </p:nvPicPr>
+        <p:blipFill>
+          <a:blip r:embed="rId3"/>
+          <a:stretch>
+            <a:fillRect/>
+          </a:stretch>
+        </p:blipFill>
+        <p:spPr>
+          <a:xfrm>
+            <a:off x="11457432" y="91440"/>
+            <a:ext cx="566928" cy="566928"/>
+          </a:xfrm>
+          <a:prstGeom prst="rect">
+            <a:avLst/>
+          </a:prstGeom>
+        </p:spPr>
+      </p:pic>
     </p:spTree>
   </p:cSld>
   <p:clrMapOvr>
@@ -34716,6 +35772,54 @@
           </a:p>
         </p:txBody>
       </p:sp>
+      <p:pic>
+        <p:nvPicPr>
+          <p:cNvPr id="26" name="Picture 25" descr="logo2.png"/>
+          <p:cNvPicPr>
+            <a:picLocks noChangeAspect="1"/>
+          </p:cNvPicPr>
+          <p:nvPr/>
+        </p:nvPicPr>
+        <p:blipFill>
+          <a:blip r:embed="rId2"/>
+          <a:stretch>
+            <a:fillRect/>
+          </a:stretch>
+        </p:blipFill>
+        <p:spPr>
+          <a:xfrm>
+            <a:off x="164592" y="91440"/>
+            <a:ext cx="640080" cy="327894"/>
+          </a:xfrm>
+          <a:prstGeom prst="rect">
+            <a:avLst/>
+          </a:prstGeom>
+        </p:spPr>
+      </p:pic>
+      <p:pic>
+        <p:nvPicPr>
+          <p:cNvPr id="27" name="Picture 26" descr="logo.png"/>
+          <p:cNvPicPr>
+            <a:picLocks noChangeAspect="1"/>
+          </p:cNvPicPr>
+          <p:nvPr/>
+        </p:nvPicPr>
+        <p:blipFill>
+          <a:blip r:embed="rId3"/>
+          <a:stretch>
+            <a:fillRect/>
+          </a:stretch>
+        </p:blipFill>
+        <p:spPr>
+          <a:xfrm>
+            <a:off x="11457432" y="91440"/>
+            <a:ext cx="566928" cy="566928"/>
+          </a:xfrm>
+          <a:prstGeom prst="rect">
+            <a:avLst/>
+          </a:prstGeom>
+        </p:spPr>
+      </p:pic>
     </p:spTree>
   </p:cSld>
   <p:clrMapOvr>

</xml_diff>